<commit_message>
El registro alcanza a la realidad: mazo de la sesión 2 y temario corregidos
- Láminas 5 y 6 de la sesión 2: Copilot vive en un solo lugar (Copilot
  Chat con OneDrive y adjuntos); los dos modos ahora son por cuenta, no
  por aplicación.
- Temario: nota fechada del ajuste de Copilot en la sección de
  herramientas, prácticas de las sesiones 4 y 5 actualizadas en línea, y
  el paso 4 del protocolo pasa de «Cruzar» a «Triangular» como en los
  materiales publicados.

Co-Authored-By: Claude Fable 5 <noreply@anthropic.com>
</commit_message>
<xml_diff>
--- a/sesion-02/Sesion_02_Copilot_y_Prompting.pptx
+++ b/sesion-02/Sesion_02_Copilot_y_Prompting.pptx
@@ -2115,7 +2115,7 @@
           <a:p>
             <a:r>
               <a:rPr lang="en-US" dirty="0"/>
-              <a:t>Pídeles que abran Word y verifiquen si Copilot les ofrece hacer referencia a archivos. Dos minutos. Quien no sepa en qué modo está no puede decidir qué información pegar.</a:t>
+              <a:t>Pídeles que abran Copilot Chat con su cuenta del Instituto y verifiquen que pueden adjuntar o referenciar un archivo de OneDrive. Dos minutos. Quien no sepa en qué modo está no puede decidir qué información pegar.</a:t>
             </a:r>
             <a:endParaRPr lang="en-US" dirty="0"/>
           </a:p>
@@ -16313,7 +16313,7 @@
 
 <file path=ppt/slides/slide5.xml><?xml version="1.0" encoding="utf-8"?>
 <p:sld xmlns:a="http://schemas.openxmlformats.org/drawingml/2006/main" xmlns:r="http://schemas.openxmlformats.org/officeDocument/2006/relationships" xmlns:p="http://schemas.openxmlformats.org/presentationml/2006/main">
-  <p:cSld name="Slide 5">
+  <p:cSld name="Copilot en el INEGI">
     <p:spTree>
       <p:nvGrpSpPr>
         <p:cNvPr id="1" name=""/>
@@ -16330,14 +16330,14 @@
       </p:grpSpPr>
       <p:sp>
         <p:nvSpPr>
-          <p:cNvPr id="2" name="Text 0"/>
+          <p:cNvPr id="2" name="Text"/>
           <p:cNvSpPr txBox="1"/>
           <p:nvPr/>
         </p:nvSpPr>
         <p:spPr>
           <a:xfrm>
             <a:off x="566928" y="402336"/>
-            <a:ext cx="9229039" cy="749808"/>
+            <a:ext cx="11057839" cy="749808"/>
           </a:xfrm>
           <a:prstGeom prst="rect">
             <a:avLst/>
@@ -16349,7 +16349,7 @@
           <a:bodyPr wrap="square" lIns="0" tIns="0" rIns="0" bIns="0" rtlCol="0" anchor="t"/>
           <a:lstStyle/>
           <a:p>
-            <a:pPr algn="l" indent="0" marL="0">
+            <a:pPr indent="0" marL="0">
               <a:buNone/>
             </a:pPr>
             <a:r>
@@ -16361,7 +16361,7 @@
                 <a:ea typeface="Arial" pitchFamily="34" charset="-122"/>
                 <a:cs typeface="Arial" pitchFamily="34" charset="-120"/>
               </a:rPr>
-              <a:t>Copilot no es una página. Son seis lugares</a:t>
+              <a:t>Copilot, en el INEGI, vive en un solo lugar</a:t>
             </a:r>
             <a:endParaRPr lang="en-US" sz="3200" dirty="0"/>
           </a:p>
@@ -16369,14 +16369,14 @@
       </p:sp>
       <p:sp>
         <p:nvSpPr>
-          <p:cNvPr id="3" name="Text 1"/>
+          <p:cNvPr id="3" name="Text"/>
           <p:cNvSpPr txBox="1"/>
           <p:nvPr/>
         </p:nvSpPr>
         <p:spPr>
           <a:xfrm>
             <a:off x="566928" y="1280160"/>
-            <a:ext cx="9960559" cy="365760"/>
+            <a:ext cx="11057839" cy="731520"/>
           </a:xfrm>
           <a:prstGeom prst="rect">
             <a:avLst/>
@@ -16400,7 +16400,7 @@
                 <a:ea typeface="Calibri" pitchFamily="34" charset="-122"/>
                 <a:cs typeface="Calibri" pitchFamily="34" charset="-120"/>
               </a:rPr>
-              <a:t>Cada uno sirve para algo distinto. Hoy vas a usar por lo menos tres.</a:t>
+              <a:t>No aparece dentro de Word, Excel, Outlook ni Teams. Lo que tienes es Copilot Chat con tu cuenta del Instituto, y alcanza para todo lo que hace este curso.</a:t>
             </a:r>
             <a:endParaRPr lang="en-US" sz="1500" dirty="0"/>
           </a:p>
@@ -16408,126 +16408,18 @@
       </p:sp>
       <p:sp>
         <p:nvSpPr>
-          <p:cNvPr id="4" name="Shape 2"/>
+          <p:cNvPr id="4" name="Shape"/>
           <p:cNvSpPr/>
           <p:nvPr/>
         </p:nvSpPr>
         <p:spPr>
           <a:xfrm>
-            <a:off x="566928" y="1937791"/>
-            <a:ext cx="3503066" cy="1916405"/>
+            <a:off x="566928" y="2011680"/>
+            <a:ext cx="3503066" cy="2750000"/>
           </a:xfrm>
           <a:prstGeom prst="roundRect">
             <a:avLst>
-              <a:gd name="adj" fmla="val 3817"/>
-            </a:avLst>
-          </a:prstGeom>
-          <a:solidFill>
-            <a:srgbClr val="D7E7E7"/>
-          </a:solidFill>
-          <a:ln w="12700">
-            <a:solidFill>
-              <a:srgbClr val="D7E7E7"/>
-            </a:solidFill>
-            <a:prstDash val="solid"/>
-          </a:ln>
-        </p:spPr>
-      </p:sp>
-      <p:sp>
-        <p:nvSpPr>
-          <p:cNvPr id="5" name="Text 3"/>
-          <p:cNvSpPr txBox="1"/>
-          <p:nvPr/>
-        </p:nvSpPr>
-        <p:spPr>
-          <a:xfrm>
-            <a:off x="804672" y="2175535"/>
-            <a:ext cx="3027578" cy="311099"/>
-          </a:xfrm>
-          <a:prstGeom prst="rect">
-            <a:avLst/>
-          </a:prstGeom>
-          <a:noFill/>
-          <a:ln/>
-        </p:spPr>
-        <p:txBody>
-          <a:bodyPr wrap="square" lIns="0" tIns="0" rIns="0" bIns="0" rtlCol="0" anchor="t"/>
-          <a:lstStyle/>
-          <a:p>
-            <a:pPr indent="0" marL="0">
-              <a:buNone/>
-            </a:pPr>
-            <a:r>
-              <a:rPr lang="en-US" sz="1552" b="1" dirty="0">
-                <a:solidFill>
-                  <a:srgbClr val="16262E"/>
-                </a:solidFill>
-                <a:latin typeface="Arial" pitchFamily="34" charset="0"/>
-                <a:ea typeface="Arial" pitchFamily="34" charset="-122"/>
-                <a:cs typeface="Arial" pitchFamily="34" charset="-120"/>
-              </a:rPr>
-              <a:t>En Word</a:t>
-            </a:r>
-            <a:endParaRPr lang="en-US" sz="1552" dirty="0"/>
-          </a:p>
-        </p:txBody>
-      </p:sp>
-      <p:sp>
-        <p:nvSpPr>
-          <p:cNvPr id="6" name="Text 4"/>
-          <p:cNvSpPr txBox="1"/>
-          <p:nvPr/>
-        </p:nvSpPr>
-        <p:spPr>
-          <a:xfrm>
-            <a:off x="804672" y="2632939"/>
-            <a:ext cx="3027578" cy="1020089"/>
-          </a:xfrm>
-          <a:prstGeom prst="rect">
-            <a:avLst/>
-          </a:prstGeom>
-          <a:noFill/>
-          <a:ln/>
-        </p:spPr>
-        <p:txBody>
-          <a:bodyPr wrap="square" lIns="0" tIns="0" rIns="0" bIns="0" rtlCol="0" anchor="t"/>
-          <a:lstStyle/>
-          <a:p>
-            <a:pPr indent="0" marL="0">
-              <a:lnSpc>
-                <a:spcPct val="110000"/>
-              </a:lnSpc>
-              <a:buNone/>
-            </a:pPr>
-            <a:r>
-              <a:rPr lang="en-US" sz="1261" dirty="0">
-                <a:solidFill>
-                  <a:srgbClr val="16262E"/>
-                </a:solidFill>
-                <a:latin typeface="Calibri" pitchFamily="34" charset="0"/>
-                <a:ea typeface="Calibri" pitchFamily="34" charset="-122"/>
-                <a:cs typeface="Calibri" pitchFamily="34" charset="-120"/>
-              </a:rPr>
-              <a:t>Resumir, extraer, reescribir y ajustar el tono de un documento que ya tienes abierto. Aquí vas a estar casi toda la sesión.</a:t>
-            </a:r>
-            <a:endParaRPr lang="en-US" sz="1261" dirty="0"/>
-          </a:p>
-        </p:txBody>
-      </p:sp>
-      <p:sp>
-        <p:nvSpPr>
-          <p:cNvPr id="7" name="Shape 5"/>
-          <p:cNvSpPr/>
-          <p:nvPr/>
-        </p:nvSpPr>
-        <p:spPr>
-          <a:xfrm>
-            <a:off x="4344314" y="1937791"/>
-            <a:ext cx="3503066" cy="1916405"/>
-          </a:xfrm>
-          <a:prstGeom prst="roundRect">
-            <a:avLst>
-              <a:gd name="adj" fmla="val 3817"/>
+              <a:gd name="adj" fmla="val 2933"/>
             </a:avLst>
           </a:prstGeom>
           <a:solidFill>
@@ -16543,53 +16435,117 @@
       </p:sp>
       <p:sp>
         <p:nvSpPr>
-          <p:cNvPr id="8" name="Text 6"/>
-          <p:cNvSpPr txBox="1"/>
-          <p:nvPr/>
-        </p:nvSpPr>
-        <p:spPr>
-          <a:xfrm>
-            <a:off x="4582058" y="2175535"/>
-            <a:ext cx="3027578" cy="311099"/>
-          </a:xfrm>
-          <a:prstGeom prst="rect">
-            <a:avLst/>
-          </a:prstGeom>
-          <a:noFill/>
-          <a:ln/>
-        </p:spPr>
-        <p:txBody>
-          <a:bodyPr wrap="square" lIns="0" tIns="0" rIns="0" bIns="0" rtlCol="0" anchor="t"/>
-          <a:lstStyle/>
-          <a:p>
-            <a:pPr indent="0" marL="0">
-              <a:buNone/>
-            </a:pPr>
-            <a:r>
-              <a:rPr lang="en-US" sz="1552" b="1" dirty="0">
-                <a:solidFill>
-                  <a:srgbClr val="16262E"/>
+          <p:cNvPr id="5" name="Shape"/>
+          <p:cNvSpPr/>
+          <p:nvPr/>
+        </p:nvSpPr>
+        <p:spPr>
+          <a:xfrm>
+            <a:off x="804672" y="2231136"/>
+            <a:ext cx="420624" cy="420624"/>
+          </a:xfrm>
+          <a:prstGeom prst="ellipse">
+            <a:avLst/>
+          </a:prstGeom>
+          <a:solidFill>
+            <a:srgbClr val="2E7D7D"/>
+          </a:solidFill>
+          <a:ln w="12700">
+            <a:solidFill>
+              <a:srgbClr val="2E7D7D"/>
+            </a:solidFill>
+            <a:prstDash val="solid"/>
+          </a:ln>
+        </p:spPr>
+      </p:sp>
+      <p:sp>
+        <p:nvSpPr>
+          <p:cNvPr id="6" name="Text"/>
+          <p:cNvSpPr txBox="1"/>
+          <p:nvPr/>
+        </p:nvSpPr>
+        <p:spPr>
+          <a:xfrm>
+            <a:off x="804672" y="2231136"/>
+            <a:ext cx="420624" cy="420624"/>
+          </a:xfrm>
+          <a:prstGeom prst="rect">
+            <a:avLst/>
+          </a:prstGeom>
+          <a:noFill/>
+          <a:ln/>
+        </p:spPr>
+        <p:txBody>
+          <a:bodyPr wrap="square" lIns="0" tIns="0" rIns="0" bIns="0" rtlCol="0" anchor="ctr"/>
+          <a:lstStyle/>
+          <a:p>
+            <a:pPr algn="ctr" indent="0" marL="0">
+              <a:buNone/>
+            </a:pPr>
+            <a:r>
+              <a:rPr lang="en-US" sz="1400" b="1" dirty="0">
+                <a:solidFill>
+                  <a:srgbClr val="FFFFFF"/>
                 </a:solidFill>
                 <a:latin typeface="Arial" pitchFamily="34" charset="0"/>
                 <a:ea typeface="Arial" pitchFamily="34" charset="-122"/>
                 <a:cs typeface="Arial" pitchFamily="34" charset="-120"/>
               </a:rPr>
-              <a:t>En Excel</a:t>
-            </a:r>
-            <a:endParaRPr lang="en-US" sz="1552" dirty="0"/>
-          </a:p>
-        </p:txBody>
-      </p:sp>
-      <p:sp>
-        <p:nvSpPr>
-          <p:cNvPr id="9" name="Text 7"/>
-          <p:cNvSpPr txBox="1"/>
-          <p:nvPr/>
-        </p:nvSpPr>
-        <p:spPr>
-          <a:xfrm>
-            <a:off x="4582058" y="2632939"/>
-            <a:ext cx="3027578" cy="1020089"/>
+              <a:t>1</a:t>
+            </a:r>
+            <a:endParaRPr lang="en-US" sz="1400" dirty="0"/>
+          </a:p>
+        </p:txBody>
+      </p:sp>
+      <p:sp>
+        <p:nvSpPr>
+          <p:cNvPr id="7" name="Text"/>
+          <p:cNvSpPr txBox="1"/>
+          <p:nvPr/>
+        </p:nvSpPr>
+        <p:spPr>
+          <a:xfrm>
+            <a:off x="804672" y="2798064"/>
+            <a:ext cx="3027578" cy="583184"/>
+          </a:xfrm>
+          <a:prstGeom prst="rect">
+            <a:avLst/>
+          </a:prstGeom>
+          <a:noFill/>
+          <a:ln/>
+        </p:spPr>
+        <p:txBody>
+          <a:bodyPr wrap="square" lIns="0" tIns="0" rIns="0" bIns="0" rtlCol="0" anchor="t"/>
+          <a:lstStyle/>
+          <a:p>
+            <a:pPr indent="0" marL="0">
+              <a:buNone/>
+            </a:pPr>
+            <a:r>
+              <a:rPr lang="en-US" sz="1600" b="1" dirty="0">
+                <a:solidFill>
+                  <a:srgbClr val="16262E"/>
+                </a:solidFill>
+                <a:latin typeface="Arial" pitchFamily="34" charset="0"/>
+                <a:ea typeface="Arial" pitchFamily="34" charset="-122"/>
+                <a:cs typeface="Arial" pitchFamily="34" charset="-120"/>
+              </a:rPr>
+              <a:t>Chat con archivos adjuntos</a:t>
+            </a:r>
+            <a:endParaRPr lang="en-US" sz="1600" dirty="0"/>
+          </a:p>
+        </p:txBody>
+      </p:sp>
+      <p:sp>
+        <p:nvSpPr>
+          <p:cNvPr id="8" name="Text"/>
+          <p:cNvSpPr txBox="1"/>
+          <p:nvPr/>
+        </p:nvSpPr>
+        <p:spPr>
+          <a:xfrm>
+            <a:off x="804672" y="3455000"/>
+            <a:ext cx="3027578" cy="1260000"/>
           </a:xfrm>
           <a:prstGeom prst="rect">
             <a:avLst/>
@@ -16608,7 +16564,7 @@
               <a:buNone/>
             </a:pPr>
             <a:r>
-              <a:rPr lang="en-US" sz="1261" dirty="0">
+              <a:rPr lang="en-US" sz="1300" dirty="0">
                 <a:solidFill>
                   <a:srgbClr val="16262E"/>
                 </a:solidFill>
@@ -16616,26 +16572,26 @@
                 <a:ea typeface="Calibri" pitchFamily="34" charset="-122"/>
                 <a:cs typeface="Calibri" pitchFamily="34" charset="-120"/>
               </a:rPr>
-              <a:t>Explicar fórmulas, proponer transformaciones y ordenar datos. Lo usas el viernes para la tabla comparativa.</a:t>
-            </a:r>
-            <a:endParaRPr lang="en-US" sz="1261" dirty="0"/>
-          </a:p>
-        </p:txBody>
-      </p:sp>
-      <p:sp>
-        <p:nvSpPr>
-          <p:cNvPr id="10" name="Shape 8"/>
+              <a:t>Sube el documento al chat y trabaja sobre él: resumir, extraer, comparar, reescribir. Así corren las prácticas del curso.</a:t>
+            </a:r>
+            <a:endParaRPr lang="en-US" sz="1300" dirty="0"/>
+          </a:p>
+        </p:txBody>
+      </p:sp>
+      <p:sp>
+        <p:nvSpPr>
+          <p:cNvPr id="9" name="Shape"/>
           <p:cNvSpPr/>
           <p:nvPr/>
         </p:nvSpPr>
         <p:spPr>
           <a:xfrm>
-            <a:off x="8121701" y="1937791"/>
-            <a:ext cx="3503066" cy="1916405"/>
+            <a:off x="4344314" y="2011680"/>
+            <a:ext cx="3503066" cy="2750000"/>
           </a:xfrm>
           <a:prstGeom prst="roundRect">
             <a:avLst>
-              <a:gd name="adj" fmla="val 3817"/>
+              <a:gd name="adj" fmla="val 2933"/>
             </a:avLst>
           </a:prstGeom>
           <a:solidFill>
@@ -16651,53 +16607,117 @@
       </p:sp>
       <p:sp>
         <p:nvSpPr>
-          <p:cNvPr id="11" name="Text 9"/>
-          <p:cNvSpPr txBox="1"/>
-          <p:nvPr/>
-        </p:nvSpPr>
-        <p:spPr>
-          <a:xfrm>
-            <a:off x="8359445" y="2175535"/>
-            <a:ext cx="3027578" cy="311099"/>
-          </a:xfrm>
-          <a:prstGeom prst="rect">
-            <a:avLst/>
-          </a:prstGeom>
-          <a:noFill/>
-          <a:ln/>
-        </p:spPr>
-        <p:txBody>
-          <a:bodyPr wrap="square" lIns="0" tIns="0" rIns="0" bIns="0" rtlCol="0" anchor="t"/>
-          <a:lstStyle/>
-          <a:p>
-            <a:pPr indent="0" marL="0">
-              <a:buNone/>
-            </a:pPr>
-            <a:r>
-              <a:rPr lang="en-US" sz="1552" b="1" dirty="0">
-                <a:solidFill>
-                  <a:srgbClr val="16262E"/>
+          <p:cNvPr id="10" name="Shape"/>
+          <p:cNvSpPr/>
+          <p:nvPr/>
+        </p:nvSpPr>
+        <p:spPr>
+          <a:xfrm>
+            <a:off x="4582058" y="2231136"/>
+            <a:ext cx="420624" cy="420624"/>
+          </a:xfrm>
+          <a:prstGeom prst="ellipse">
+            <a:avLst/>
+          </a:prstGeom>
+          <a:solidFill>
+            <a:srgbClr val="2E7D7D"/>
+          </a:solidFill>
+          <a:ln w="12700">
+            <a:solidFill>
+              <a:srgbClr val="2E7D7D"/>
+            </a:solidFill>
+            <a:prstDash val="solid"/>
+          </a:ln>
+        </p:spPr>
+      </p:sp>
+      <p:sp>
+        <p:nvSpPr>
+          <p:cNvPr id="11" name="Text"/>
+          <p:cNvSpPr txBox="1"/>
+          <p:nvPr/>
+        </p:nvSpPr>
+        <p:spPr>
+          <a:xfrm>
+            <a:off x="4582058" y="2231136"/>
+            <a:ext cx="420624" cy="420624"/>
+          </a:xfrm>
+          <a:prstGeom prst="rect">
+            <a:avLst/>
+          </a:prstGeom>
+          <a:noFill/>
+          <a:ln/>
+        </p:spPr>
+        <p:txBody>
+          <a:bodyPr wrap="square" lIns="0" tIns="0" rIns="0" bIns="0" rtlCol="0" anchor="ctr"/>
+          <a:lstStyle/>
+          <a:p>
+            <a:pPr algn="ctr" indent="0" marL="0">
+              <a:buNone/>
+            </a:pPr>
+            <a:r>
+              <a:rPr lang="en-US" sz="1400" b="1" dirty="0">
+                <a:solidFill>
+                  <a:srgbClr val="FFFFFF"/>
                 </a:solidFill>
                 <a:latin typeface="Arial" pitchFamily="34" charset="0"/>
                 <a:ea typeface="Arial" pitchFamily="34" charset="-122"/>
                 <a:cs typeface="Arial" pitchFamily="34" charset="-120"/>
               </a:rPr>
-              <a:t>En PowerPoint</a:t>
-            </a:r>
-            <a:endParaRPr lang="en-US" sz="1552" dirty="0"/>
-          </a:p>
-        </p:txBody>
-      </p:sp>
-      <p:sp>
-        <p:nvSpPr>
-          <p:cNvPr id="12" name="Text 10"/>
-          <p:cNvSpPr txBox="1"/>
-          <p:nvPr/>
-        </p:nvSpPr>
-        <p:spPr>
-          <a:xfrm>
-            <a:off x="8359445" y="2632939"/>
-            <a:ext cx="3027578" cy="1020089"/>
+              <a:t>2</a:t>
+            </a:r>
+            <a:endParaRPr lang="en-US" sz="1400" dirty="0"/>
+          </a:p>
+        </p:txBody>
+      </p:sp>
+      <p:sp>
+        <p:nvSpPr>
+          <p:cNvPr id="12" name="Text"/>
+          <p:cNvSpPr txBox="1"/>
+          <p:nvPr/>
+        </p:nvSpPr>
+        <p:spPr>
+          <a:xfrm>
+            <a:off x="4582058" y="2798064"/>
+            <a:ext cx="3027578" cy="583184"/>
+          </a:xfrm>
+          <a:prstGeom prst="rect">
+            <a:avLst/>
+          </a:prstGeom>
+          <a:noFill/>
+          <a:ln/>
+        </p:spPr>
+        <p:txBody>
+          <a:bodyPr wrap="square" lIns="0" tIns="0" rIns="0" bIns="0" rtlCol="0" anchor="t"/>
+          <a:lstStyle/>
+          <a:p>
+            <a:pPr indent="0" marL="0">
+              <a:buNone/>
+            </a:pPr>
+            <a:r>
+              <a:rPr lang="en-US" sz="1600" b="1" dirty="0">
+                <a:solidFill>
+                  <a:srgbClr val="16262E"/>
+                </a:solidFill>
+                <a:latin typeface="Arial" pitchFamily="34" charset="0"/>
+                <a:ea typeface="Arial" pitchFamily="34" charset="-122"/>
+                <a:cs typeface="Arial" pitchFamily="34" charset="-120"/>
+              </a:rPr>
+              <a:t>Acceso a tu OneDrive</a:t>
+            </a:r>
+            <a:endParaRPr lang="en-US" sz="1600" dirty="0"/>
+          </a:p>
+        </p:txBody>
+      </p:sp>
+      <p:sp>
+        <p:nvSpPr>
+          <p:cNvPr id="13" name="Text"/>
+          <p:cNvSpPr txBox="1"/>
+          <p:nvPr/>
+        </p:nvSpPr>
+        <p:spPr>
+          <a:xfrm>
+            <a:off x="4582058" y="3455000"/>
+            <a:ext cx="3027578" cy="1260000"/>
           </a:xfrm>
           <a:prstGeom prst="rect">
             <a:avLst/>
@@ -16716,7 +16736,7 @@
               <a:buNone/>
             </a:pPr>
             <a:r>
-              <a:rPr lang="en-US" sz="1261" dirty="0">
+              <a:rPr lang="en-US" sz="1300" dirty="0">
                 <a:solidFill>
                   <a:srgbClr val="16262E"/>
                 </a:solidFill>
@@ -16724,26 +16744,26 @@
                 <a:ea typeface="Calibri" pitchFamily="34" charset="-122"/>
                 <a:cs typeface="Calibri" pitchFamily="34" charset="-120"/>
               </a:rPr>
-              <a:t>Armar y reordenar láminas a partir de un documento. Uso ligero en estas dos semanas.</a:t>
-            </a:r>
-            <a:endParaRPr lang="en-US" sz="1261" dirty="0"/>
-          </a:p>
-        </p:txBody>
-      </p:sp>
-      <p:sp>
-        <p:nvSpPr>
-          <p:cNvPr id="13" name="Shape 11"/>
+              <a:t>Puede leer y referenciar los archivos de tu OneDrive institucional sin volverlos a subir. Lo comprobamos hoy en vivo.</a:t>
+            </a:r>
+            <a:endParaRPr lang="en-US" sz="1300" dirty="0"/>
+          </a:p>
+        </p:txBody>
+      </p:sp>
+      <p:sp>
+        <p:nvSpPr>
+          <p:cNvPr id="14" name="Shape"/>
           <p:cNvSpPr/>
           <p:nvPr/>
         </p:nvSpPr>
         <p:spPr>
           <a:xfrm>
-            <a:off x="566928" y="4128516"/>
-            <a:ext cx="3503066" cy="1916405"/>
+            <a:off x="8121701" y="2011680"/>
+            <a:ext cx="3503066" cy="2750000"/>
           </a:xfrm>
           <a:prstGeom prst="roundRect">
             <a:avLst>
-              <a:gd name="adj" fmla="val 3817"/>
+              <a:gd name="adj" fmla="val 2933"/>
             </a:avLst>
           </a:prstGeom>
           <a:solidFill>
@@ -16759,53 +16779,117 @@
       </p:sp>
       <p:sp>
         <p:nvSpPr>
-          <p:cNvPr id="14" name="Text 12"/>
-          <p:cNvSpPr txBox="1"/>
-          <p:nvPr/>
-        </p:nvSpPr>
-        <p:spPr>
-          <a:xfrm>
-            <a:off x="804672" y="4366260"/>
-            <a:ext cx="3027578" cy="311099"/>
-          </a:xfrm>
-          <a:prstGeom prst="rect">
-            <a:avLst/>
-          </a:prstGeom>
-          <a:noFill/>
-          <a:ln/>
-        </p:spPr>
-        <p:txBody>
-          <a:bodyPr wrap="square" lIns="0" tIns="0" rIns="0" bIns="0" rtlCol="0" anchor="t"/>
-          <a:lstStyle/>
-          <a:p>
-            <a:pPr indent="0" marL="0">
-              <a:buNone/>
-            </a:pPr>
-            <a:r>
-              <a:rPr lang="en-US" sz="1552" b="1" dirty="0">
-                <a:solidFill>
-                  <a:srgbClr val="16262E"/>
+          <p:cNvPr id="15" name="Shape"/>
+          <p:cNvSpPr/>
+          <p:nvPr/>
+        </p:nvSpPr>
+        <p:spPr>
+          <a:xfrm>
+            <a:off x="8359445" y="2231136"/>
+            <a:ext cx="420624" cy="420624"/>
+          </a:xfrm>
+          <a:prstGeom prst="ellipse">
+            <a:avLst/>
+          </a:prstGeom>
+          <a:solidFill>
+            <a:srgbClr val="2E7D7D"/>
+          </a:solidFill>
+          <a:ln w="12700">
+            <a:solidFill>
+              <a:srgbClr val="2E7D7D"/>
+            </a:solidFill>
+            <a:prstDash val="solid"/>
+          </a:ln>
+        </p:spPr>
+      </p:sp>
+      <p:sp>
+        <p:nvSpPr>
+          <p:cNvPr id="16" name="Text"/>
+          <p:cNvSpPr txBox="1"/>
+          <p:nvPr/>
+        </p:nvSpPr>
+        <p:spPr>
+          <a:xfrm>
+            <a:off x="8359445" y="2231136"/>
+            <a:ext cx="420624" cy="420624"/>
+          </a:xfrm>
+          <a:prstGeom prst="rect">
+            <a:avLst/>
+          </a:prstGeom>
+          <a:noFill/>
+          <a:ln/>
+        </p:spPr>
+        <p:txBody>
+          <a:bodyPr wrap="square" lIns="0" tIns="0" rIns="0" bIns="0" rtlCol="0" anchor="ctr"/>
+          <a:lstStyle/>
+          <a:p>
+            <a:pPr algn="ctr" indent="0" marL="0">
+              <a:buNone/>
+            </a:pPr>
+            <a:r>
+              <a:rPr lang="en-US" sz="1400" b="1" dirty="0">
+                <a:solidFill>
+                  <a:srgbClr val="FFFFFF"/>
                 </a:solidFill>
                 <a:latin typeface="Arial" pitchFamily="34" charset="0"/>
                 <a:ea typeface="Arial" pitchFamily="34" charset="-122"/>
                 <a:cs typeface="Arial" pitchFamily="34" charset="-120"/>
               </a:rPr>
-              <a:t>En Outlook</a:t>
-            </a:r>
-            <a:endParaRPr lang="en-US" sz="1552" dirty="0"/>
-          </a:p>
-        </p:txBody>
-      </p:sp>
-      <p:sp>
-        <p:nvSpPr>
-          <p:cNvPr id="15" name="Text 13"/>
-          <p:cNvSpPr txBox="1"/>
-          <p:nvPr/>
-        </p:nvSpPr>
-        <p:spPr>
-          <a:xfrm>
-            <a:off x="804672" y="4823663"/>
-            <a:ext cx="3027578" cy="1020089"/>
+              <a:t>3</a:t>
+            </a:r>
+            <a:endParaRPr lang="en-US" sz="1400" dirty="0"/>
+          </a:p>
+        </p:txBody>
+      </p:sp>
+      <p:sp>
+        <p:nvSpPr>
+          <p:cNvPr id="17" name="Text"/>
+          <p:cNvSpPr txBox="1"/>
+          <p:nvPr/>
+        </p:nvSpPr>
+        <p:spPr>
+          <a:xfrm>
+            <a:off x="8359445" y="2798064"/>
+            <a:ext cx="3027578" cy="583184"/>
+          </a:xfrm>
+          <a:prstGeom prst="rect">
+            <a:avLst/>
+          </a:prstGeom>
+          <a:noFill/>
+          <a:ln/>
+        </p:spPr>
+        <p:txBody>
+          <a:bodyPr wrap="square" lIns="0" tIns="0" rIns="0" bIns="0" rtlCol="0" anchor="t"/>
+          <a:lstStyle/>
+          <a:p>
+            <a:pPr indent="0" marL="0">
+              <a:buNone/>
+            </a:pPr>
+            <a:r>
+              <a:rPr lang="en-US" sz="1600" b="1" dirty="0">
+                <a:solidFill>
+                  <a:srgbClr val="16262E"/>
+                </a:solidFill>
+                <a:latin typeface="Arial" pitchFamily="34" charset="0"/>
+                <a:ea typeface="Arial" pitchFamily="34" charset="-122"/>
+                <a:cs typeface="Arial" pitchFamily="34" charset="-120"/>
+              </a:rPr>
+              <a:t>Outlook y Teams, sin asistente</a:t>
+            </a:r>
+            <a:endParaRPr lang="en-US" sz="1600" dirty="0"/>
+          </a:p>
+        </p:txBody>
+      </p:sp>
+      <p:sp>
+        <p:nvSpPr>
+          <p:cNvPr id="18" name="Text"/>
+          <p:cNvSpPr txBox="1"/>
+          <p:nvPr/>
+        </p:nvSpPr>
+        <p:spPr>
+          <a:xfrm>
+            <a:off x="8359445" y="3455000"/>
+            <a:ext cx="3027578" cy="1260000"/>
           </a:xfrm>
           <a:prstGeom prst="rect">
             <a:avLst/>
@@ -16824,7 +16908,7 @@
               <a:buNone/>
             </a:pPr>
             <a:r>
-              <a:rPr lang="en-US" sz="1261" dirty="0">
+              <a:rPr lang="en-US" sz="1300" dirty="0">
                 <a:solidFill>
                   <a:srgbClr val="16262E"/>
                 </a:solidFill>
@@ -16832,34 +16916,34 @@
                 <a:ea typeface="Calibri" pitchFamily="34" charset="-122"/>
                 <a:cs typeface="Calibri" pitchFamily="34" charset="-120"/>
               </a:rPr>
-              <a:t>Resumir hilos largos, sacar los compromisos y redactar respuestas. Con una trampa que ves después del receso.</a:t>
-            </a:r>
-            <a:endParaRPr lang="en-US" sz="1261" dirty="0"/>
-          </a:p>
-        </p:txBody>
-      </p:sp>
-      <p:sp>
-        <p:nvSpPr>
-          <p:cNvPr id="16" name="Shape 14"/>
+              <a:t>El correo y las reuniones siguen igual que siempre; lo que no hay es Copilot adentro. Esas prácticas se hacen adjuntando el archivo al chat.</a:t>
+            </a:r>
+            <a:endParaRPr lang="en-US" sz="1300" dirty="0"/>
+          </a:p>
+        </p:txBody>
+      </p:sp>
+      <p:sp>
+        <p:nvSpPr>
+          <p:cNvPr id="19" name="Shape"/>
           <p:cNvSpPr/>
           <p:nvPr/>
         </p:nvSpPr>
         <p:spPr>
           <a:xfrm>
-            <a:off x="4344314" y="4128516"/>
-            <a:ext cx="3503066" cy="1916405"/>
+            <a:off x="566928" y="5193792"/>
+            <a:ext cx="11057839" cy="777240"/>
           </a:xfrm>
           <a:prstGeom prst="roundRect">
             <a:avLst>
-              <a:gd name="adj" fmla="val 3817"/>
+              <a:gd name="adj" fmla="val 8235"/>
             </a:avLst>
           </a:prstGeom>
           <a:solidFill>
-            <a:srgbClr val="F2F5F6"/>
+            <a:srgbClr val="16262E"/>
           </a:solidFill>
           <a:ln w="12700">
             <a:solidFill>
-              <a:srgbClr val="F2F5F6"/>
+              <a:srgbClr val="16262E"/>
             </a:solidFill>
             <a:prstDash val="solid"/>
           </a:ln>
@@ -16867,62 +16951,23 @@
       </p:sp>
       <p:sp>
         <p:nvSpPr>
-          <p:cNvPr id="17" name="Text 15"/>
-          <p:cNvSpPr txBox="1"/>
-          <p:nvPr/>
-        </p:nvSpPr>
-        <p:spPr>
-          <a:xfrm>
-            <a:off x="4582058" y="4366260"/>
-            <a:ext cx="3027578" cy="311099"/>
-          </a:xfrm>
-          <a:prstGeom prst="rect">
-            <a:avLst/>
-          </a:prstGeom>
-          <a:noFill/>
-          <a:ln/>
-        </p:spPr>
-        <p:txBody>
-          <a:bodyPr wrap="square" lIns="0" tIns="0" rIns="0" bIns="0" rtlCol="0" anchor="t"/>
-          <a:lstStyle/>
-          <a:p>
-            <a:pPr indent="0" marL="0">
-              <a:buNone/>
-            </a:pPr>
-            <a:r>
-              <a:rPr lang="en-US" sz="1552" b="1" dirty="0">
-                <a:solidFill>
-                  <a:srgbClr val="16262E"/>
-                </a:solidFill>
-                <a:latin typeface="Arial" pitchFamily="34" charset="0"/>
-                <a:ea typeface="Arial" pitchFamily="34" charset="-122"/>
-                <a:cs typeface="Arial" pitchFamily="34" charset="-120"/>
-              </a:rPr>
-              <a:t>En Teams</a:t>
-            </a:r>
-            <a:endParaRPr lang="en-US" sz="1552" dirty="0"/>
-          </a:p>
-        </p:txBody>
-      </p:sp>
-      <p:sp>
-        <p:nvSpPr>
-          <p:cNvPr id="18" name="Text 16"/>
-          <p:cNvSpPr txBox="1"/>
-          <p:nvPr/>
-        </p:nvSpPr>
-        <p:spPr>
-          <a:xfrm>
-            <a:off x="4582058" y="4823663"/>
-            <a:ext cx="3027578" cy="1020089"/>
-          </a:xfrm>
-          <a:prstGeom prst="rect">
-            <a:avLst/>
-          </a:prstGeom>
-          <a:noFill/>
-          <a:ln/>
-        </p:spPr>
-        <p:txBody>
-          <a:bodyPr wrap="square" lIns="0" tIns="0" rIns="0" bIns="0" rtlCol="0" anchor="t"/>
+          <p:cNvPr id="20" name="Text"/>
+          <p:cNvSpPr txBox="1"/>
+          <p:nvPr/>
+        </p:nvSpPr>
+        <p:spPr>
+          <a:xfrm>
+            <a:off x="841248" y="5193792"/>
+            <a:ext cx="10509199" cy="777240"/>
+          </a:xfrm>
+          <a:prstGeom prst="rect">
+            <a:avLst/>
+          </a:prstGeom>
+          <a:noFill/>
+          <a:ln/>
+        </p:spPr>
+        <p:txBody>
+          <a:bodyPr wrap="square" lIns="0" tIns="0" rIns="0" bIns="0" rtlCol="0" anchor="ctr"/>
           <a:lstStyle/>
           <a:p>
             <a:pPr indent="0" marL="0">
@@ -16932,125 +16977,17 @@
               <a:buNone/>
             </a:pPr>
             <a:r>
-              <a:rPr lang="en-US" sz="1261" dirty="0">
-                <a:solidFill>
-                  <a:srgbClr val="16262E"/>
+              <a:rPr lang="en-US" sz="1350" dirty="0">
+                <a:solidFill>
+                  <a:srgbClr val="FFFFFF"/>
                 </a:solidFill>
                 <a:latin typeface="Calibri" pitchFamily="34" charset="0"/>
                 <a:ea typeface="Calibri" pitchFamily="34" charset="-122"/>
                 <a:cs typeface="Calibri" pitchFamily="34" charset="-120"/>
               </a:rPr>
-              <a:t>Sacar la minuta de una reunión a partir de la transcripción. Con otra trampa.</a:t>
-            </a:r>
-            <a:endParaRPr lang="en-US" sz="1261" dirty="0"/>
-          </a:p>
-        </p:txBody>
-      </p:sp>
-      <p:sp>
-        <p:nvSpPr>
-          <p:cNvPr id="19" name="Shape 17"/>
-          <p:cNvSpPr/>
-          <p:nvPr/>
-        </p:nvSpPr>
-        <p:spPr>
-          <a:xfrm>
-            <a:off x="8121701" y="4128516"/>
-            <a:ext cx="3503066" cy="1916405"/>
-          </a:xfrm>
-          <a:prstGeom prst="roundRect">
-            <a:avLst>
-              <a:gd name="adj" fmla="val 3817"/>
-            </a:avLst>
-          </a:prstGeom>
-          <a:solidFill>
-            <a:srgbClr val="F2F5F6"/>
-          </a:solidFill>
-          <a:ln w="12700">
-            <a:solidFill>
-              <a:srgbClr val="F2F5F6"/>
-            </a:solidFill>
-            <a:prstDash val="solid"/>
-          </a:ln>
-        </p:spPr>
-      </p:sp>
-      <p:sp>
-        <p:nvSpPr>
-          <p:cNvPr id="20" name="Text 18"/>
-          <p:cNvSpPr txBox="1"/>
-          <p:nvPr/>
-        </p:nvSpPr>
-        <p:spPr>
-          <a:xfrm>
-            <a:off x="8359445" y="4366260"/>
-            <a:ext cx="3027578" cy="311099"/>
-          </a:xfrm>
-          <a:prstGeom prst="rect">
-            <a:avLst/>
-          </a:prstGeom>
-          <a:noFill/>
-          <a:ln/>
-        </p:spPr>
-        <p:txBody>
-          <a:bodyPr wrap="square" lIns="0" tIns="0" rIns="0" bIns="0" rtlCol="0" anchor="t"/>
-          <a:lstStyle/>
-          <a:p>
-            <a:pPr indent="0" marL="0">
-              <a:buNone/>
-            </a:pPr>
-            <a:r>
-              <a:rPr lang="en-US" sz="1552" b="1" dirty="0">
-                <a:solidFill>
-                  <a:srgbClr val="16262E"/>
-                </a:solidFill>
-                <a:latin typeface="Arial" pitchFamily="34" charset="0"/>
-                <a:ea typeface="Arial" pitchFamily="34" charset="-122"/>
-                <a:cs typeface="Arial" pitchFamily="34" charset="-120"/>
-              </a:rPr>
-              <a:t>En el navegador</a:t>
-            </a:r>
-            <a:endParaRPr lang="en-US" sz="1552" dirty="0"/>
-          </a:p>
-        </p:txBody>
-      </p:sp>
-      <p:sp>
-        <p:nvSpPr>
-          <p:cNvPr id="21" name="Text 19"/>
-          <p:cNvSpPr txBox="1"/>
-          <p:nvPr/>
-        </p:nvSpPr>
-        <p:spPr>
-          <a:xfrm>
-            <a:off x="8359445" y="4823663"/>
-            <a:ext cx="3027578" cy="1020089"/>
-          </a:xfrm>
-          <a:prstGeom prst="rect">
-            <a:avLst/>
-          </a:prstGeom>
-          <a:noFill/>
-          <a:ln/>
-        </p:spPr>
-        <p:txBody>
-          <a:bodyPr wrap="square" lIns="0" tIns="0" rIns="0" bIns="0" rtlCol="0" anchor="t"/>
-          <a:lstStyle/>
-          <a:p>
-            <a:pPr indent="0" marL="0">
-              <a:lnSpc>
-                <a:spcPct val="110000"/>
-              </a:lnSpc>
-              <a:buNone/>
-            </a:pPr>
-            <a:r>
-              <a:rPr lang="en-US" sz="1261" dirty="0">
-                <a:solidFill>
-                  <a:srgbClr val="16262E"/>
-                </a:solidFill>
-                <a:latin typeface="Calibri" pitchFamily="34" charset="0"/>
-                <a:ea typeface="Calibri" pitchFamily="34" charset="-122"/>
-                <a:cs typeface="Calibri" pitchFamily="34" charset="-120"/>
-              </a:rPr>
-              <a:t>El chat general. Sirve para explorar, pero es el que menos sabe de tu trabajo.</a:t>
-            </a:r>
-            <a:endParaRPr lang="en-US" sz="1261" dirty="0"/>
+              <a:t>Donde un material del curso diga «Copilot en Word» o «dentro de Excel», léelo como «Copilot Chat con el archivo adjunto». La lámina que sigue trae los dos modos.</a:t>
+            </a:r>
+            <a:endParaRPr lang="en-US" sz="1350" dirty="0"/>
           </a:p>
         </p:txBody>
       </p:sp>
@@ -17283,7 +17220,7 @@
                 <a:ea typeface="Calibri" pitchFamily="34" charset="-122"/>
                 <a:cs typeface="Calibri" pitchFamily="34" charset="-120"/>
               </a:rPr>
-              <a:t>Copilot en Word</a:t>
+              <a:t>Copilot Chat</a:t>
             </a:r>
             <a:endParaRPr lang="en-US" sz="1250" dirty="0"/>
           </a:p>
@@ -17349,7 +17286,7 @@
                 <a:ea typeface="Calibri" pitchFamily="34" charset="-122"/>
                 <a:cs typeface="Calibri" pitchFamily="34" charset="-120"/>
               </a:rPr>
-              <a:t>Copilot en Excel</a:t>
+              <a:t>Con tu cuenta del INEGI</a:t>
             </a:r>
             <a:endParaRPr lang="en-US" sz="1250" dirty="0"/>
           </a:p>
@@ -17415,7 +17352,7 @@
                 <a:ea typeface="Calibri" pitchFamily="34" charset="-122"/>
                 <a:cs typeface="Calibri" pitchFamily="34" charset="-120"/>
               </a:rPr>
-              <a:t>Copilot en Outlook</a:t>
+              <a:t>Tus archivos de OneDrive</a:t>
             </a:r>
             <a:endParaRPr lang="en-US" sz="1250" dirty="0"/>
           </a:p>
@@ -17481,7 +17418,7 @@
                 <a:ea typeface="Calibri" pitchFamily="34" charset="-122"/>
                 <a:cs typeface="Calibri" pitchFamily="34" charset="-120"/>
               </a:rPr>
-              <a:t>Copilot en Teams</a:t>
+              <a:t>Documentos adjuntos</a:t>
             </a:r>
             <a:endParaRPr lang="en-US" sz="1250" dirty="0"/>
           </a:p>
@@ -17489,14 +17426,171 @@
       </p:sp>
       <p:sp>
         <p:nvSpPr>
-          <p:cNvPr id="14" name="Shape 12"/>
+          <p:cNvPr id="18" name="Text 16"/>
+          <p:cNvSpPr txBox="1"/>
+          <p:nvPr/>
+        </p:nvSpPr>
+        <p:spPr>
+          <a:xfrm>
+            <a:off x="841248" y="4206240"/>
+            <a:ext cx="5312015" cy="1371600"/>
+          </a:xfrm>
+          <a:prstGeom prst="rect">
+            <a:avLst/>
+          </a:prstGeom>
+          <a:noFill/>
+          <a:ln/>
+        </p:spPr>
+        <p:txBody>
+          <a:bodyPr wrap="square" lIns="0" tIns="0" rIns="0" bIns="0" rtlCol="0" anchor="t"/>
+          <a:lstStyle/>
+          <a:p>
+            <a:pPr indent="0" marL="0">
+              <a:lnSpc>
+                <a:spcPct val="114000"/>
+              </a:lnSpc>
+              <a:spcAft>
+                <a:spcPts val="600"/>
+              </a:spcAft>
+              <a:buNone/>
+            </a:pPr>
+            <a:r>
+              <a:rPr lang="en-US" sz="1300" dirty="0">
+                <a:solidFill>
+                  <a:srgbClr val="16262E"/>
+                </a:solidFill>
+                <a:latin typeface="Calibri" pitchFamily="34" charset="0"/>
+                <a:ea typeface="Calibri" pitchFamily="34" charset="-122"/>
+                <a:cs typeface="Calibri" pitchFamily="34" charset="-120"/>
+              </a:rPr>
+              <a:t>Con tu cuenta institucional quedas dentro del contrato: tus prompts y tus archivos no entrenan modelos.</a:t>
+            </a:r>
+            <a:endParaRPr lang="en-US" sz="1300" dirty="0"/>
+          </a:p>
+          <a:p>
+            <a:pPr indent="0" marL="0">
+              <a:lnSpc>
+                <a:spcPct val="114000"/>
+              </a:lnSpc>
+              <a:spcAft>
+                <a:spcPts val="600"/>
+              </a:spcAft>
+              <a:buNone/>
+            </a:pPr>
+            <a:r>
+              <a:rPr lang="en-US" sz="1300" dirty="0">
+                <a:solidFill>
+                  <a:srgbClr val="16262E"/>
+                </a:solidFill>
+                <a:latin typeface="Calibri" pitchFamily="34" charset="0"/>
+                <a:ea typeface="Calibri" pitchFamily="34" charset="-122"/>
+                <a:cs typeface="Calibri" pitchFamily="34" charset="-120"/>
+              </a:rPr>
+              <a:t>Copilot Chat lee lo que le adjuntas y tus archivos de OneDrive: ahí vive el contexto de tu trabajo.</a:t>
+            </a:r>
+            <a:endParaRPr lang="en-US" sz="1300" dirty="0"/>
+          </a:p>
+          <a:p>
+            <a:pPr indent="0" marL="0">
+              <a:lnSpc>
+                <a:spcPct val="114000"/>
+              </a:lnSpc>
+              <a:spcAft>
+                <a:spcPts val="600"/>
+              </a:spcAft>
+              <a:buNone/>
+            </a:pPr>
+            <a:r>
+              <a:rPr lang="en-US" sz="1300" dirty="0">
+                <a:solidFill>
+                  <a:srgbClr val="16262E"/>
+                </a:solidFill>
+                <a:latin typeface="Calibri" pitchFamily="34" charset="0"/>
+                <a:ea typeface="Calibri" pitchFamily="34" charset="-122"/>
+                <a:cs typeface="Calibri" pitchFamily="34" charset="-120"/>
+              </a:rPr>
+              <a:t>Es el único lugar donde puedes trabajar con información amarilla.</a:t>
+            </a:r>
+            <a:endParaRPr lang="en-US" sz="1300" dirty="0"/>
+          </a:p>
+        </p:txBody>
+      </p:sp>
+      <p:sp>
+        <p:nvSpPr>
+          <p:cNvPr id="19" name="Shape 17"/>
           <p:cNvSpPr/>
           <p:nvPr/>
         </p:nvSpPr>
         <p:spPr>
           <a:xfrm>
-            <a:off x="841248" y="3547872"/>
-            <a:ext cx="2573711" cy="457200"/>
+            <a:off x="6793343" y="1810512"/>
+            <a:ext cx="4831424" cy="3950208"/>
+          </a:xfrm>
+          <a:prstGeom prst="roundRect">
+            <a:avLst>
+              <a:gd name="adj" fmla="val 2778"/>
+            </a:avLst>
+          </a:prstGeom>
+          <a:solidFill>
+            <a:srgbClr val="F2F5F6"/>
+          </a:solidFill>
+          <a:ln w="19050">
+            <a:solidFill>
+              <a:srgbClr val="5A6B73"/>
+            </a:solidFill>
+            <a:prstDash val="dash"/>
+          </a:ln>
+        </p:spPr>
+      </p:sp>
+      <p:sp>
+        <p:nvSpPr>
+          <p:cNvPr id="20" name="Text 18"/>
+          <p:cNvSpPr txBox="1"/>
+          <p:nvPr/>
+        </p:nvSpPr>
+        <p:spPr>
+          <a:xfrm>
+            <a:off x="7067663" y="2029968"/>
+            <a:ext cx="4282784" cy="365760"/>
+          </a:xfrm>
+          <a:prstGeom prst="rect">
+            <a:avLst/>
+          </a:prstGeom>
+          <a:noFill/>
+          <a:ln/>
+        </p:spPr>
+        <p:txBody>
+          <a:bodyPr wrap="square" lIns="0" tIns="0" rIns="0" bIns="0" rtlCol="0" anchor="ctr"/>
+          <a:lstStyle/>
+          <a:p>
+            <a:pPr indent="0" marL="0">
+              <a:buNone/>
+            </a:pPr>
+            <a:r>
+              <a:rPr lang="en-US" sz="1700" b="1" dirty="0">
+                <a:solidFill>
+                  <a:srgbClr val="5A6B73"/>
+                </a:solidFill>
+                <a:latin typeface="Arial" pitchFamily="34" charset="0"/>
+                <a:ea typeface="Arial" pitchFamily="34" charset="-122"/>
+                <a:cs typeface="Arial" pitchFamily="34" charset="-120"/>
+              </a:rPr>
+              <a:t>Fuera del contrato</a:t>
+            </a:r>
+            <a:endParaRPr lang="en-US" sz="1700" dirty="0"/>
+          </a:p>
+        </p:txBody>
+      </p:sp>
+      <p:sp>
+        <p:nvSpPr>
+          <p:cNvPr id="21" name="Shape 19"/>
+          <p:cNvSpPr/>
+          <p:nvPr/>
+        </p:nvSpPr>
+        <p:spPr>
+          <a:xfrm>
+            <a:off x="7067663" y="2523744"/>
+            <a:ext cx="4282784" cy="457200"/>
           </a:xfrm>
           <a:prstGeom prst="roundRect">
             <a:avLst>
@@ -17516,14 +17610,14 @@
       </p:sp>
       <p:sp>
         <p:nvSpPr>
-          <p:cNvPr id="15" name="Text 13"/>
-          <p:cNvSpPr txBox="1"/>
-          <p:nvPr/>
-        </p:nvSpPr>
-        <p:spPr>
-          <a:xfrm>
-            <a:off x="987552" y="3547872"/>
-            <a:ext cx="2281103" cy="420624"/>
+          <p:cNvPr id="22" name="Text 20"/>
+          <p:cNvSpPr txBox="1"/>
+          <p:nvPr/>
+        </p:nvSpPr>
+        <p:spPr>
+          <a:xfrm>
+            <a:off x="7213967" y="2523744"/>
+            <a:ext cx="3990176" cy="420624"/>
           </a:xfrm>
           <a:prstGeom prst="rect">
             <a:avLst/>
@@ -17547,7 +17641,7 @@
                 <a:ea typeface="Calibri" pitchFamily="34" charset="-122"/>
                 <a:cs typeface="Calibri" pitchFamily="34" charset="-120"/>
               </a:rPr>
-              <a:t>SharePoint</a:t>
+              <a:t>Copilot sin tu cuenta</a:t>
             </a:r>
             <a:endParaRPr lang="en-US" sz="1250" dirty="0"/>
           </a:p>
@@ -17555,14 +17649,14 @@
       </p:sp>
       <p:sp>
         <p:nvSpPr>
-          <p:cNvPr id="16" name="Shape 14"/>
+          <p:cNvPr id="23" name="Shape 21"/>
           <p:cNvSpPr/>
           <p:nvPr/>
         </p:nvSpPr>
         <p:spPr>
           <a:xfrm>
-            <a:off x="3579551" y="3547872"/>
-            <a:ext cx="2573711" cy="457200"/>
+            <a:off x="7067663" y="3035808"/>
+            <a:ext cx="4282784" cy="457200"/>
           </a:xfrm>
           <a:prstGeom prst="roundRect">
             <a:avLst>
@@ -17582,14 +17676,14 @@
       </p:sp>
       <p:sp>
         <p:nvSpPr>
-          <p:cNvPr id="17" name="Text 15"/>
-          <p:cNvSpPr txBox="1"/>
-          <p:nvPr/>
-        </p:nvSpPr>
-        <p:spPr>
-          <a:xfrm>
-            <a:off x="3725855" y="3547872"/>
-            <a:ext cx="2281103" cy="420624"/>
+          <p:cNvPr id="24" name="Text 22"/>
+          <p:cNvSpPr txBox="1"/>
+          <p:nvPr/>
+        </p:nvSpPr>
+        <p:spPr>
+          <a:xfrm>
+            <a:off x="7213967" y="3035808"/>
+            <a:ext cx="3990176" cy="420624"/>
           </a:xfrm>
           <a:prstGeom prst="rect">
             <a:avLst/>
@@ -17613,7 +17707,7 @@
                 <a:ea typeface="Calibri" pitchFamily="34" charset="-122"/>
                 <a:cs typeface="Calibri" pitchFamily="34" charset="-120"/>
               </a:rPr>
-              <a:t>OneDrive</a:t>
+              <a:t>ChatGPT, Claude, Gemini</a:t>
             </a:r>
             <a:endParaRPr lang="en-US" sz="1250" dirty="0"/>
           </a:p>
@@ -17621,170 +17715,13 @@
       </p:sp>
       <p:sp>
         <p:nvSpPr>
-          <p:cNvPr id="18" name="Text 16"/>
-          <p:cNvSpPr txBox="1"/>
-          <p:nvPr/>
-        </p:nvSpPr>
-        <p:spPr>
-          <a:xfrm>
-            <a:off x="841248" y="4206240"/>
-            <a:ext cx="5312015" cy="1371600"/>
-          </a:xfrm>
-          <a:prstGeom prst="rect">
-            <a:avLst/>
-          </a:prstGeom>
-          <a:noFill/>
-          <a:ln/>
-        </p:spPr>
-        <p:txBody>
-          <a:bodyPr wrap="square" lIns="0" tIns="0" rIns="0" bIns="0" rtlCol="0" anchor="t"/>
-          <a:lstStyle/>
-          <a:p>
-            <a:pPr indent="0" marL="0">
-              <a:lnSpc>
-                <a:spcPct val="114000"/>
-              </a:lnSpc>
-              <a:spcAft>
-                <a:spcPts val="600"/>
-              </a:spcAft>
-              <a:buNone/>
-            </a:pPr>
-            <a:r>
-              <a:rPr lang="en-US" sz="1300" dirty="0">
-                <a:solidFill>
-                  <a:srgbClr val="16262E"/>
-                </a:solidFill>
-                <a:latin typeface="Calibri" pitchFamily="34" charset="0"/>
-                <a:ea typeface="Calibri" pitchFamily="34" charset="-122"/>
-                <a:cs typeface="Calibri" pitchFamily="34" charset="-120"/>
-              </a:rPr>
-              <a:t>Aquí Copilot puede leer tus correos, tus archivos de SharePoint y tus chats de Teams.</a:t>
-            </a:r>
-            <a:endParaRPr lang="en-US" sz="1300" dirty="0"/>
-          </a:p>
-          <a:p>
-            <a:pPr indent="0" marL="0">
-              <a:lnSpc>
-                <a:spcPct val="114000"/>
-              </a:lnSpc>
-              <a:spcAft>
-                <a:spcPts val="600"/>
-              </a:spcAft>
-              <a:buNone/>
-            </a:pPr>
-            <a:r>
-              <a:rPr lang="en-US" sz="1300" dirty="0">
-                <a:solidFill>
-                  <a:srgbClr val="16262E"/>
-                </a:solidFill>
-                <a:latin typeface="Calibri" pitchFamily="34" charset="0"/>
-                <a:ea typeface="Calibri" pitchFamily="34" charset="-122"/>
-                <a:cs typeface="Calibri" pitchFamily="34" charset="-120"/>
-              </a:rPr>
-              <a:t>Es donde aporta valor de verdad, porque conoce el contexto de tu trabajo.</a:t>
-            </a:r>
-            <a:endParaRPr lang="en-US" sz="1300" dirty="0"/>
-          </a:p>
-          <a:p>
-            <a:pPr indent="0" marL="0">
-              <a:lnSpc>
-                <a:spcPct val="114000"/>
-              </a:lnSpc>
-              <a:spcAft>
-                <a:spcPts val="600"/>
-              </a:spcAft>
-              <a:buNone/>
-            </a:pPr>
-            <a:r>
-              <a:rPr lang="en-US" sz="1300" dirty="0">
-                <a:solidFill>
-                  <a:srgbClr val="16262E"/>
-                </a:solidFill>
-                <a:latin typeface="Calibri" pitchFamily="34" charset="0"/>
-                <a:ea typeface="Calibri" pitchFamily="34" charset="-122"/>
-                <a:cs typeface="Calibri" pitchFamily="34" charset="-120"/>
-              </a:rPr>
-              <a:t>Es el único lugar donde puedes trabajar con información amarilla.</a:t>
-            </a:r>
-            <a:endParaRPr lang="en-US" sz="1300" dirty="0"/>
-          </a:p>
-        </p:txBody>
-      </p:sp>
-      <p:sp>
-        <p:nvSpPr>
-          <p:cNvPr id="19" name="Shape 17"/>
+          <p:cNvPr id="25" name="Shape 23"/>
           <p:cNvSpPr/>
           <p:nvPr/>
         </p:nvSpPr>
         <p:spPr>
           <a:xfrm>
-            <a:off x="6793343" y="1810512"/>
-            <a:ext cx="4831424" cy="3950208"/>
-          </a:xfrm>
-          <a:prstGeom prst="roundRect">
-            <a:avLst>
-              <a:gd name="adj" fmla="val 2778"/>
-            </a:avLst>
-          </a:prstGeom>
-          <a:solidFill>
-            <a:srgbClr val="F2F5F6"/>
-          </a:solidFill>
-          <a:ln w="19050">
-            <a:solidFill>
-              <a:srgbClr val="5A6B73"/>
-            </a:solidFill>
-            <a:prstDash val="dash"/>
-          </a:ln>
-        </p:spPr>
-      </p:sp>
-      <p:sp>
-        <p:nvSpPr>
-          <p:cNvPr id="20" name="Text 18"/>
-          <p:cNvSpPr txBox="1"/>
-          <p:nvPr/>
-        </p:nvSpPr>
-        <p:spPr>
-          <a:xfrm>
-            <a:off x="7067663" y="2029968"/>
-            <a:ext cx="4282784" cy="365760"/>
-          </a:xfrm>
-          <a:prstGeom prst="rect">
-            <a:avLst/>
-          </a:prstGeom>
-          <a:noFill/>
-          <a:ln/>
-        </p:spPr>
-        <p:txBody>
-          <a:bodyPr wrap="square" lIns="0" tIns="0" rIns="0" bIns="0" rtlCol="0" anchor="ctr"/>
-          <a:lstStyle/>
-          <a:p>
-            <a:pPr indent="0" marL="0">
-              <a:buNone/>
-            </a:pPr>
-            <a:r>
-              <a:rPr lang="en-US" sz="1700" b="1" dirty="0">
-                <a:solidFill>
-                  <a:srgbClr val="5A6B73"/>
-                </a:solidFill>
-                <a:latin typeface="Arial" pitchFamily="34" charset="0"/>
-                <a:ea typeface="Arial" pitchFamily="34" charset="-122"/>
-                <a:cs typeface="Arial" pitchFamily="34" charset="-120"/>
-              </a:rPr>
-              <a:t>Fuera del contrato</a:t>
-            </a:r>
-            <a:endParaRPr lang="en-US" sz="1700" dirty="0"/>
-          </a:p>
-        </p:txBody>
-      </p:sp>
-      <p:sp>
-        <p:nvSpPr>
-          <p:cNvPr id="21" name="Shape 19"/>
-          <p:cNvSpPr/>
-          <p:nvPr/>
-        </p:nvSpPr>
-        <p:spPr>
-          <a:xfrm>
-            <a:off x="7067663" y="2523744"/>
+            <a:off x="7067663" y="3547872"/>
             <a:ext cx="4282784" cy="457200"/>
           </a:xfrm>
           <a:prstGeom prst="roundRect">
@@ -17805,13 +17742,13 @@
       </p:sp>
       <p:sp>
         <p:nvSpPr>
-          <p:cNvPr id="22" name="Text 20"/>
-          <p:cNvSpPr txBox="1"/>
-          <p:nvPr/>
-        </p:nvSpPr>
-        <p:spPr>
-          <a:xfrm>
-            <a:off x="7213967" y="2523744"/>
+          <p:cNvPr id="26" name="Text 24"/>
+          <p:cNvSpPr txBox="1"/>
+          <p:nvPr/>
+        </p:nvSpPr>
+        <p:spPr>
+          <a:xfrm>
+            <a:off x="7213967" y="3547872"/>
             <a:ext cx="3990176" cy="420624"/>
           </a:xfrm>
           <a:prstGeom prst="rect">
@@ -17836,7 +17773,7 @@
                 <a:ea typeface="Calibri" pitchFamily="34" charset="-122"/>
                 <a:cs typeface="Calibri" pitchFamily="34" charset="-120"/>
               </a:rPr>
-              <a:t>Chat del navegador</a:t>
+              <a:t>Perplexity, You.com</a:t>
             </a:r>
             <a:endParaRPr lang="en-US" sz="1250" dirty="0"/>
           </a:p>
@@ -17844,13 +17781,13 @@
       </p:sp>
       <p:sp>
         <p:nvSpPr>
-          <p:cNvPr id="23" name="Shape 21"/>
+          <p:cNvPr id="27" name="Shape 25"/>
           <p:cNvSpPr/>
           <p:nvPr/>
         </p:nvSpPr>
         <p:spPr>
           <a:xfrm>
-            <a:off x="7067663" y="3035808"/>
+            <a:off x="7067663" y="4059936"/>
             <a:ext cx="4282784" cy="457200"/>
           </a:xfrm>
           <a:prstGeom prst="roundRect">
@@ -17871,138 +17808,6 @@
       </p:sp>
       <p:sp>
         <p:nvSpPr>
-          <p:cNvPr id="24" name="Text 22"/>
-          <p:cNvSpPr txBox="1"/>
-          <p:nvPr/>
-        </p:nvSpPr>
-        <p:spPr>
-          <a:xfrm>
-            <a:off x="7213967" y="3035808"/>
-            <a:ext cx="3990176" cy="420624"/>
-          </a:xfrm>
-          <a:prstGeom prst="rect">
-            <a:avLst/>
-          </a:prstGeom>
-          <a:noFill/>
-          <a:ln/>
-        </p:spPr>
-        <p:txBody>
-          <a:bodyPr wrap="square" lIns="0" tIns="0" rIns="0" bIns="0" rtlCol="0" anchor="ctr"/>
-          <a:lstStyle/>
-          <a:p>
-            <a:pPr algn="ctr" indent="0" marL="0">
-              <a:buNone/>
-            </a:pPr>
-            <a:r>
-              <a:rPr lang="en-US" sz="1250" b="1" dirty="0">
-                <a:solidFill>
-                  <a:srgbClr val="16262E"/>
-                </a:solidFill>
-                <a:latin typeface="Calibri" pitchFamily="34" charset="0"/>
-                <a:ea typeface="Calibri" pitchFamily="34" charset="-122"/>
-                <a:cs typeface="Calibri" pitchFamily="34" charset="-120"/>
-              </a:rPr>
-              <a:t>ChatGPT, Claude, Gemini</a:t>
-            </a:r>
-            <a:endParaRPr lang="en-US" sz="1250" dirty="0"/>
-          </a:p>
-        </p:txBody>
-      </p:sp>
-      <p:sp>
-        <p:nvSpPr>
-          <p:cNvPr id="25" name="Shape 23"/>
-          <p:cNvSpPr/>
-          <p:nvPr/>
-        </p:nvSpPr>
-        <p:spPr>
-          <a:xfrm>
-            <a:off x="7067663" y="3547872"/>
-            <a:ext cx="4282784" cy="457200"/>
-          </a:xfrm>
-          <a:prstGeom prst="roundRect">
-            <a:avLst>
-              <a:gd name="adj" fmla="val 50000"/>
-            </a:avLst>
-          </a:prstGeom>
-          <a:solidFill>
-            <a:srgbClr val="FFFFFF"/>
-          </a:solidFill>
-          <a:ln w="12700">
-            <a:solidFill>
-              <a:srgbClr val="FFFFFF"/>
-            </a:solidFill>
-            <a:prstDash val="solid"/>
-          </a:ln>
-        </p:spPr>
-      </p:sp>
-      <p:sp>
-        <p:nvSpPr>
-          <p:cNvPr id="26" name="Text 24"/>
-          <p:cNvSpPr txBox="1"/>
-          <p:nvPr/>
-        </p:nvSpPr>
-        <p:spPr>
-          <a:xfrm>
-            <a:off x="7213967" y="3547872"/>
-            <a:ext cx="3990176" cy="420624"/>
-          </a:xfrm>
-          <a:prstGeom prst="rect">
-            <a:avLst/>
-          </a:prstGeom>
-          <a:noFill/>
-          <a:ln/>
-        </p:spPr>
-        <p:txBody>
-          <a:bodyPr wrap="square" lIns="0" tIns="0" rIns="0" bIns="0" rtlCol="0" anchor="ctr"/>
-          <a:lstStyle/>
-          <a:p>
-            <a:pPr algn="ctr" indent="0" marL="0">
-              <a:buNone/>
-            </a:pPr>
-            <a:r>
-              <a:rPr lang="en-US" sz="1250" b="1" dirty="0">
-                <a:solidFill>
-                  <a:srgbClr val="16262E"/>
-                </a:solidFill>
-                <a:latin typeface="Calibri" pitchFamily="34" charset="0"/>
-                <a:ea typeface="Calibri" pitchFamily="34" charset="-122"/>
-                <a:cs typeface="Calibri" pitchFamily="34" charset="-120"/>
-              </a:rPr>
-              <a:t>Perplexity, You.com</a:t>
-            </a:r>
-            <a:endParaRPr lang="en-US" sz="1250" dirty="0"/>
-          </a:p>
-        </p:txBody>
-      </p:sp>
-      <p:sp>
-        <p:nvSpPr>
-          <p:cNvPr id="27" name="Shape 25"/>
-          <p:cNvSpPr/>
-          <p:nvPr/>
-        </p:nvSpPr>
-        <p:spPr>
-          <a:xfrm>
-            <a:off x="7067663" y="4059936"/>
-            <a:ext cx="4282784" cy="457200"/>
-          </a:xfrm>
-          <a:prstGeom prst="roundRect">
-            <a:avLst>
-              <a:gd name="adj" fmla="val 50000"/>
-            </a:avLst>
-          </a:prstGeom>
-          <a:solidFill>
-            <a:srgbClr val="FFFFFF"/>
-          </a:solidFill>
-          <a:ln w="12700">
-            <a:solidFill>
-              <a:srgbClr val="FFFFFF"/>
-            </a:solidFill>
-            <a:prstDash val="solid"/>
-          </a:ln>
-        </p:spPr>
-      </p:sp>
-      <p:sp>
-        <p:nvSpPr>
           <p:cNvPr id="28" name="Text 26"/>
           <p:cNvSpPr txBox="1"/>
           <p:nvPr/>
@@ -18168,7 +17973,7 @@
                 <a:ea typeface="Calibri" pitchFamily="34" charset="-122"/>
                 <a:cs typeface="Calibri" pitchFamily="34" charset="-120"/>
               </a:rPr>
-              <a:t>Lo primero de la práctica de hoy es que averigües en cuál de los dos modos estás trabajando tú.</a:t>
+              <a:t>La primera verificación de hoy: entra a Copilot Chat con tu cuenta del Instituto y confirma que puedes ver tus archivos de OneDrive.</a:t>
             </a:r>
             <a:endParaRPr lang="en-US" sz="1300" dirty="0"/>
           </a:p>

</xml_diff>